<commit_message>
Összefésülés + 1 dia
</commit_message>
<xml_diff>
--- a/DózsaCsárda_PA_FB_PG.pptx
+++ b/DózsaCsárda_PA_FB_PG.pptx
@@ -5,7 +5,7 @@
     <p:sldMasterId id="2147483648" r:id="rId1"/>
   </p:sldMasterIdLst>
   <p:notesMasterIdLst>
-    <p:notesMasterId r:id="rId28"/>
+    <p:notesMasterId r:id="rId29"/>
   </p:notesMasterIdLst>
   <p:sldIdLst>
     <p:sldId id="256" r:id="rId2"/>
@@ -34,6 +34,7 @@
     <p:sldId id="270" r:id="rId25"/>
     <p:sldId id="283" r:id="rId26"/>
     <p:sldId id="280" r:id="rId27"/>
+    <p:sldId id="287" r:id="rId28"/>
   </p:sldIdLst>
   <p:sldSz cx="12192000" cy="6858000"/>
   <p:notesSz cx="6858000" cy="9144000"/>
@@ -13174,6 +13175,558 @@
 </p:sld>
 </file>
 
+<file path=ppt/slides/slide27.xml><?xml version="1.0" encoding="utf-8"?>
+<p:sld xmlns:a="http://schemas.openxmlformats.org/drawingml/2006/main" xmlns:r="http://schemas.openxmlformats.org/officeDocument/2006/relationships" xmlns:p="http://schemas.openxmlformats.org/presentationml/2006/main">
+  <p:cSld>
+    <p:bg>
+      <p:bgPr>
+        <a:solidFill>
+          <a:schemeClr val="accent4">
+            <a:lumMod val="20000"/>
+            <a:lumOff val="80000"/>
+          </a:schemeClr>
+        </a:solidFill>
+        <a:effectLst/>
+      </p:bgPr>
+    </p:bg>
+    <p:spTree>
+      <p:nvGrpSpPr>
+        <p:cNvPr id="1" name="">
+          <a:extLst>
+            <a:ext uri="{FF2B5EF4-FFF2-40B4-BE49-F238E27FC236}">
+              <a16:creationId xmlns:a16="http://schemas.microsoft.com/office/drawing/2014/main" id="{E16657FB-E914-0BD8-241A-425FA2DDD351}"/>
+            </a:ext>
+          </a:extLst>
+        </p:cNvPr>
+        <p:cNvGrpSpPr/>
+        <p:nvPr/>
+      </p:nvGrpSpPr>
+      <p:grpSpPr>
+        <a:xfrm>
+          <a:off x="0" y="0"/>
+          <a:ext cx="0" cy="0"/>
+          <a:chOff x="0" y="0"/>
+          <a:chExt cx="0" cy="0"/>
+        </a:xfrm>
+      </p:grpSpPr>
+      <p:sp>
+        <p:nvSpPr>
+          <p:cNvPr id="4" name="Téglalap 3">
+            <a:extLst>
+              <a:ext uri="{FF2B5EF4-FFF2-40B4-BE49-F238E27FC236}">
+                <a16:creationId xmlns:a16="http://schemas.microsoft.com/office/drawing/2014/main" id="{8954174F-1ECB-C531-91CA-330F0694812F}"/>
+              </a:ext>
+            </a:extLst>
+          </p:cNvPr>
+          <p:cNvSpPr/>
+          <p:nvPr/>
+        </p:nvSpPr>
+        <p:spPr>
+          <a:xfrm>
+            <a:off x="0" y="0"/>
+            <a:ext cx="12192000" cy="819150"/>
+          </a:xfrm>
+          <a:prstGeom prst="rect">
+            <a:avLst/>
+          </a:prstGeom>
+          <a:solidFill>
+            <a:schemeClr val="accent1">
+              <a:lumMod val="60000"/>
+              <a:lumOff val="40000"/>
+            </a:schemeClr>
+          </a:solidFill>
+          <a:ln>
+            <a:noFill/>
+          </a:ln>
+        </p:spPr>
+        <p:style>
+          <a:lnRef idx="2">
+            <a:schemeClr val="accent1">
+              <a:shade val="50000"/>
+            </a:schemeClr>
+          </a:lnRef>
+          <a:fillRef idx="1">
+            <a:schemeClr val="accent1"/>
+          </a:fillRef>
+          <a:effectRef idx="0">
+            <a:schemeClr val="accent1"/>
+          </a:effectRef>
+          <a:fontRef idx="minor">
+            <a:schemeClr val="lt1"/>
+          </a:fontRef>
+        </p:style>
+        <p:txBody>
+          <a:bodyPr rtlCol="0" anchor="ctr"/>
+          <a:lstStyle/>
+          <a:p>
+            <a:pPr algn="ctr"/>
+            <a:endParaRPr lang="hu-HU">
+              <a:solidFill>
+                <a:schemeClr val="tx1"/>
+              </a:solidFill>
+            </a:endParaRPr>
+          </a:p>
+        </p:txBody>
+      </p:sp>
+      <p:sp>
+        <p:nvSpPr>
+          <p:cNvPr id="2" name="Szövegdoboz 1">
+            <a:extLst>
+              <a:ext uri="{FF2B5EF4-FFF2-40B4-BE49-F238E27FC236}">
+                <a16:creationId xmlns:a16="http://schemas.microsoft.com/office/drawing/2014/main" id="{FC3185CA-9556-F2A5-08F5-D51EF214ED5E}"/>
+              </a:ext>
+            </a:extLst>
+          </p:cNvPr>
+          <p:cNvSpPr txBox="1"/>
+          <p:nvPr/>
+        </p:nvSpPr>
+        <p:spPr>
+          <a:xfrm>
+            <a:off x="2801383" y="24854"/>
+            <a:ext cx="6589234" cy="769441"/>
+          </a:xfrm>
+          <a:prstGeom prst="rect">
+            <a:avLst/>
+          </a:prstGeom>
+          <a:noFill/>
+        </p:spPr>
+        <p:txBody>
+          <a:bodyPr wrap="square" lIns="91440" tIns="45720" rIns="91440" bIns="45720" rtlCol="0" anchor="t">
+            <a:spAutoFit/>
+          </a:bodyPr>
+          <a:lstStyle/>
+          <a:p>
+            <a:pPr algn="ctr"/>
+            <a:r>
+              <a:rPr lang="hu-HU" sz="4400" b="1" dirty="0">
+                <a:ln w="6350">
+                  <a:solidFill>
+                    <a:schemeClr val="accent1">
+                      <a:lumMod val="75000"/>
+                    </a:schemeClr>
+                  </a:solidFill>
+                </a:ln>
+                <a:solidFill>
+                  <a:schemeClr val="bg1"/>
+                </a:solidFill>
+                <a:latin typeface="Ink Free"/>
+              </a:rPr>
+              <a:t>Szerver elindítása</a:t>
+            </a:r>
+            <a:endParaRPr lang="hu-HU" sz="4400" b="1" dirty="0">
+              <a:ln w="6350">
+                <a:solidFill>
+                  <a:srgbClr val="5B9BD5">
+                    <a:lumMod val="75000"/>
+                  </a:srgbClr>
+                </a:solidFill>
+              </a:ln>
+              <a:solidFill>
+                <a:schemeClr val="bg1"/>
+              </a:solidFill>
+              <a:latin typeface="Ink Free"/>
+            </a:endParaRPr>
+          </a:p>
+        </p:txBody>
+      </p:sp>
+      <p:pic>
+        <p:nvPicPr>
+          <p:cNvPr id="14" name="Kép 13" descr="A képen gyertya látható&#10;&#10;Lehet, hogy az AI által létrehozott tartalom helytelen.">
+            <a:extLst>
+              <a:ext uri="{FF2B5EF4-FFF2-40B4-BE49-F238E27FC236}">
+                <a16:creationId xmlns:a16="http://schemas.microsoft.com/office/drawing/2014/main" id="{AF240267-F5DC-4808-E9BD-C2C799C1699B}"/>
+              </a:ext>
+            </a:extLst>
+          </p:cNvPr>
+          <p:cNvPicPr>
+            <a:picLocks noChangeAspect="1"/>
+          </p:cNvPicPr>
+          <p:nvPr/>
+        </p:nvPicPr>
+        <p:blipFill>
+          <a:blip r:embed="rId2"/>
+          <a:stretch>
+            <a:fillRect/>
+          </a:stretch>
+        </p:blipFill>
+        <p:spPr>
+          <a:xfrm>
+            <a:off x="87751" y="58187"/>
+            <a:ext cx="722857" cy="707199"/>
+          </a:xfrm>
+          <a:prstGeom prst="rect">
+            <a:avLst/>
+          </a:prstGeom>
+        </p:spPr>
+      </p:pic>
+      <p:pic>
+        <p:nvPicPr>
+          <p:cNvPr id="2050" name="Picture 2" descr="A képen szöveg, képernyőkép, Betűtípus látható&#10;&#10;Lehet, hogy az AI által létrehozott tartalom helytelen.">
+            <a:extLst>
+              <a:ext uri="{FF2B5EF4-FFF2-40B4-BE49-F238E27FC236}">
+                <a16:creationId xmlns:a16="http://schemas.microsoft.com/office/drawing/2014/main" id="{0FF959F0-0FFA-426E-B236-18EFC4AB6E8D}"/>
+              </a:ext>
+            </a:extLst>
+          </p:cNvPr>
+          <p:cNvPicPr>
+            <a:picLocks noChangeAspect="1" noChangeArrowheads="1"/>
+          </p:cNvPicPr>
+          <p:nvPr/>
+        </p:nvPicPr>
+        <p:blipFill>
+          <a:blip r:embed="rId3">
+            <a:extLst>
+              <a:ext uri="{28A0092B-C50C-407E-A947-70E740481C1C}">
+                <a14:useLocalDpi xmlns:a14="http://schemas.microsoft.com/office/drawing/2010/main" val="0"/>
+              </a:ext>
+            </a:extLst>
+          </a:blip>
+          <a:srcRect/>
+          <a:stretch>
+            <a:fillRect/>
+          </a:stretch>
+        </p:blipFill>
+        <p:spPr bwMode="auto">
+          <a:xfrm>
+            <a:off x="235792" y="857250"/>
+            <a:ext cx="4629150" cy="2571750"/>
+          </a:xfrm>
+          <a:prstGeom prst="rect">
+            <a:avLst/>
+          </a:prstGeom>
+          <a:noFill/>
+          <a:extLst>
+            <a:ext uri="{909E8E84-426E-40DD-AFC4-6F175D3DCCD1}">
+              <a14:hiddenFill xmlns:a14="http://schemas.microsoft.com/office/drawing/2010/main">
+                <a:solidFill>
+                  <a:srgbClr val="FFFFFF"/>
+                </a:solidFill>
+              </a14:hiddenFill>
+            </a:ext>
+          </a:extLst>
+        </p:spPr>
+      </p:pic>
+      <p:sp>
+        <p:nvSpPr>
+          <p:cNvPr id="12" name="Szövegdoboz 11">
+            <a:extLst>
+              <a:ext uri="{FF2B5EF4-FFF2-40B4-BE49-F238E27FC236}">
+                <a16:creationId xmlns:a16="http://schemas.microsoft.com/office/drawing/2014/main" id="{C9275FDE-A41B-401C-B814-BF30E7E93E85}"/>
+              </a:ext>
+            </a:extLst>
+          </p:cNvPr>
+          <p:cNvSpPr txBox="1"/>
+          <p:nvPr/>
+        </p:nvSpPr>
+        <p:spPr>
+          <a:xfrm>
+            <a:off x="3048778" y="3244334"/>
+            <a:ext cx="6097554" cy="369332"/>
+          </a:xfrm>
+          <a:prstGeom prst="rect">
+            <a:avLst/>
+          </a:prstGeom>
+          <a:noFill/>
+        </p:spPr>
+        <p:txBody>
+          <a:bodyPr wrap="square">
+            <a:spAutoFit/>
+          </a:bodyPr>
+          <a:lstStyle/>
+          <a:p>
+            <a:r>
+              <a:rPr lang="hu-HU" b="0" i="0" dirty="0">
+                <a:solidFill>
+                  <a:srgbClr val="000000"/>
+                </a:solidFill>
+                <a:effectLst/>
+                <a:latin typeface="Times New Roman" panose="02020603050405020304" pitchFamily="18" charset="0"/>
+              </a:rPr>
+              <a:t> </a:t>
+            </a:r>
+            <a:endParaRPr lang="hu-HU" dirty="0"/>
+          </a:p>
+        </p:txBody>
+      </p:sp>
+      <p:sp>
+        <p:nvSpPr>
+          <p:cNvPr id="15" name="Szövegdoboz 14">
+            <a:extLst>
+              <a:ext uri="{FF2B5EF4-FFF2-40B4-BE49-F238E27FC236}">
+                <a16:creationId xmlns:a16="http://schemas.microsoft.com/office/drawing/2014/main" id="{E94674D1-C8CC-4DD4-8F12-F4FD7FFF9DE3}"/>
+              </a:ext>
+            </a:extLst>
+          </p:cNvPr>
+          <p:cNvSpPr txBox="1"/>
+          <p:nvPr/>
+        </p:nvSpPr>
+        <p:spPr>
+          <a:xfrm>
+            <a:off x="4942892" y="1062245"/>
+            <a:ext cx="6097554" cy="646331"/>
+          </a:xfrm>
+          <a:prstGeom prst="rect">
+            <a:avLst/>
+          </a:prstGeom>
+          <a:noFill/>
+        </p:spPr>
+        <p:txBody>
+          <a:bodyPr wrap="square">
+            <a:spAutoFit/>
+          </a:bodyPr>
+          <a:lstStyle/>
+          <a:p>
+            <a:r>
+              <a:rPr lang="hu-HU" sz="1800" b="0" i="0" u="none" strike="noStrike">
+                <a:solidFill>
+                  <a:srgbClr val="BF9000"/>
+                </a:solidFill>
+                <a:effectLst/>
+                <a:latin typeface="Calibri" panose="020F0502020204030204" pitchFamily="34" charset="0"/>
+              </a:rPr>
+              <a:t>A RUN_SEED értéke dönti el, hogy fel kell-e tölteni az adatbázist alap adatokkal, vagy sem.</a:t>
+            </a:r>
+            <a:r>
+              <a:rPr lang="hu-HU" sz="1800" b="0" i="0">
+                <a:solidFill>
+                  <a:srgbClr val="000000"/>
+                </a:solidFill>
+                <a:effectLst/>
+                <a:latin typeface="Calibri" panose="020F0502020204030204" pitchFamily="34" charset="0"/>
+              </a:rPr>
+              <a:t>​</a:t>
+            </a:r>
+            <a:endParaRPr lang="hu-HU" dirty="0"/>
+          </a:p>
+        </p:txBody>
+      </p:sp>
+      <p:sp>
+        <p:nvSpPr>
+          <p:cNvPr id="17" name="Szövegdoboz 16">
+            <a:extLst>
+              <a:ext uri="{FF2B5EF4-FFF2-40B4-BE49-F238E27FC236}">
+                <a16:creationId xmlns:a16="http://schemas.microsoft.com/office/drawing/2014/main" id="{8FD366AF-3BBD-44C2-BF37-771A45B01135}"/>
+              </a:ext>
+            </a:extLst>
+          </p:cNvPr>
+          <p:cNvSpPr txBox="1"/>
+          <p:nvPr/>
+        </p:nvSpPr>
+        <p:spPr>
+          <a:xfrm>
+            <a:off x="4864942" y="2451231"/>
+            <a:ext cx="4157760" cy="646331"/>
+          </a:xfrm>
+          <a:prstGeom prst="rect">
+            <a:avLst/>
+          </a:prstGeom>
+          <a:noFill/>
+        </p:spPr>
+        <p:txBody>
+          <a:bodyPr wrap="square">
+            <a:spAutoFit/>
+          </a:bodyPr>
+          <a:lstStyle/>
+          <a:p>
+            <a:r>
+              <a:rPr lang="hu-HU" sz="1800" b="0" i="0" u="none" strike="noStrike" dirty="0">
+                <a:solidFill>
+                  <a:srgbClr val="BF9000"/>
+                </a:solidFill>
+                <a:effectLst/>
+                <a:latin typeface="Calibri" panose="020F0502020204030204" pitchFamily="34" charset="0"/>
+              </a:rPr>
+              <a:t>Ha </a:t>
+            </a:r>
+            <a:r>
+              <a:rPr lang="hu-HU" sz="1800" b="0" i="0" u="none" strike="noStrike" dirty="0" err="1">
+                <a:solidFill>
+                  <a:srgbClr val="BF9000"/>
+                </a:solidFill>
+                <a:effectLst/>
+                <a:latin typeface="Calibri" panose="020F0502020204030204" pitchFamily="34" charset="0"/>
+              </a:rPr>
+              <a:t>True</a:t>
+            </a:r>
+            <a:r>
+              <a:rPr lang="hu-HU" sz="1800" b="0" i="0" u="none" strike="noStrike" dirty="0">
+                <a:solidFill>
+                  <a:srgbClr val="BF9000"/>
+                </a:solidFill>
+                <a:effectLst/>
+                <a:latin typeface="Calibri" panose="020F0502020204030204" pitchFamily="34" charset="0"/>
+              </a:rPr>
+              <a:t>, akkor feltölti, ha </a:t>
+            </a:r>
+            <a:r>
+              <a:rPr lang="hu-HU" sz="1800" b="0" i="0" u="none" strike="noStrike" dirty="0" err="1">
+                <a:solidFill>
+                  <a:srgbClr val="BF9000"/>
+                </a:solidFill>
+                <a:effectLst/>
+                <a:latin typeface="Calibri" panose="020F0502020204030204" pitchFamily="34" charset="0"/>
+              </a:rPr>
+              <a:t>false</a:t>
+            </a:r>
+            <a:r>
+              <a:rPr lang="hu-HU" sz="1800" b="0" i="0" u="none" strike="noStrike" dirty="0">
+                <a:solidFill>
+                  <a:srgbClr val="BF9000"/>
+                </a:solidFill>
+                <a:effectLst/>
+                <a:latin typeface="Calibri" panose="020F0502020204030204" pitchFamily="34" charset="0"/>
+              </a:rPr>
+              <a:t> akkor nem tölti fel adatokkal</a:t>
+            </a:r>
+            <a:r>
+              <a:rPr lang="hu-HU" sz="1800" b="0" i="0" dirty="0">
+                <a:solidFill>
+                  <a:srgbClr val="000000"/>
+                </a:solidFill>
+                <a:effectLst/>
+                <a:latin typeface="Calibri" panose="020F0502020204030204" pitchFamily="34" charset="0"/>
+              </a:rPr>
+              <a:t>​</a:t>
+            </a:r>
+            <a:endParaRPr lang="hu-HU" dirty="0"/>
+          </a:p>
+        </p:txBody>
+      </p:sp>
+      <p:pic>
+        <p:nvPicPr>
+          <p:cNvPr id="2052" name="Picture 4" descr="A képen szöveg, képernyőkép, Betűtípus, sor látható&#10;&#10;Lehet, hogy az AI által létrehozott tartalom helytelen.">
+            <a:extLst>
+              <a:ext uri="{FF2B5EF4-FFF2-40B4-BE49-F238E27FC236}">
+                <a16:creationId xmlns:a16="http://schemas.microsoft.com/office/drawing/2014/main" id="{1050CC27-98F0-440E-8370-EB278E728039}"/>
+              </a:ext>
+            </a:extLst>
+          </p:cNvPr>
+          <p:cNvPicPr>
+            <a:picLocks noChangeAspect="1" noChangeArrowheads="1"/>
+          </p:cNvPicPr>
+          <p:nvPr/>
+        </p:nvPicPr>
+        <p:blipFill>
+          <a:blip r:embed="rId4">
+            <a:extLst>
+              <a:ext uri="{28A0092B-C50C-407E-A947-70E740481C1C}">
+                <a14:useLocalDpi xmlns:a14="http://schemas.microsoft.com/office/drawing/2010/main" val="0"/>
+              </a:ext>
+            </a:extLst>
+          </a:blip>
+          <a:srcRect/>
+          <a:stretch>
+            <a:fillRect/>
+          </a:stretch>
+        </p:blipFill>
+        <p:spPr bwMode="auto">
+          <a:xfrm>
+            <a:off x="317144" y="4299945"/>
+            <a:ext cx="8086725" cy="666750"/>
+          </a:xfrm>
+          <a:prstGeom prst="rect">
+            <a:avLst/>
+          </a:prstGeom>
+          <a:noFill/>
+          <a:extLst>
+            <a:ext uri="{909E8E84-426E-40DD-AFC4-6F175D3DCCD1}">
+              <a14:hiddenFill xmlns:a14="http://schemas.microsoft.com/office/drawing/2010/main">
+                <a:solidFill>
+                  <a:srgbClr val="FFFFFF"/>
+                </a:solidFill>
+              </a14:hiddenFill>
+            </a:ext>
+          </a:extLst>
+        </p:spPr>
+      </p:pic>
+      <p:sp>
+        <p:nvSpPr>
+          <p:cNvPr id="20" name="Szövegdoboz 19">
+            <a:extLst>
+              <a:ext uri="{FF2B5EF4-FFF2-40B4-BE49-F238E27FC236}">
+                <a16:creationId xmlns:a16="http://schemas.microsoft.com/office/drawing/2014/main" id="{83A30A70-7B63-44B5-9414-F6588F24C0A8}"/>
+              </a:ext>
+            </a:extLst>
+          </p:cNvPr>
+          <p:cNvSpPr txBox="1"/>
+          <p:nvPr/>
+        </p:nvSpPr>
+        <p:spPr>
+          <a:xfrm>
+            <a:off x="235791" y="5022981"/>
+            <a:ext cx="8168077" cy="369332"/>
+          </a:xfrm>
+          <a:prstGeom prst="rect">
+            <a:avLst/>
+          </a:prstGeom>
+          <a:noFill/>
+        </p:spPr>
+        <p:txBody>
+          <a:bodyPr wrap="square">
+            <a:spAutoFit/>
+          </a:bodyPr>
+          <a:lstStyle/>
+          <a:p>
+            <a:r>
+              <a:rPr lang="hu-HU" sz="1800" b="0" i="0" u="none" strike="noStrike" dirty="0">
+                <a:solidFill>
+                  <a:srgbClr val="BF9000"/>
+                </a:solidFill>
+                <a:effectLst/>
+                <a:latin typeface="Calibri" panose="020F0502020204030204" pitchFamily="34" charset="0"/>
+              </a:rPr>
+              <a:t>Ha a RUN_SEED értéke </a:t>
+            </a:r>
+            <a:r>
+              <a:rPr lang="hu-HU" sz="1800" b="0" i="0" u="none" strike="noStrike" dirty="0" err="1">
+                <a:solidFill>
+                  <a:srgbClr val="BF9000"/>
+                </a:solidFill>
+                <a:effectLst/>
+                <a:latin typeface="Calibri" panose="020F0502020204030204" pitchFamily="34" charset="0"/>
+              </a:rPr>
+              <a:t>false</a:t>
+            </a:r>
+            <a:r>
+              <a:rPr lang="hu-HU" sz="1800" b="0" i="0" u="none" strike="noStrike" dirty="0">
+                <a:solidFill>
+                  <a:srgbClr val="BF9000"/>
+                </a:solidFill>
+                <a:effectLst/>
+                <a:latin typeface="Calibri" panose="020F0502020204030204" pitchFamily="34" charset="0"/>
+              </a:rPr>
+              <a:t>, akkor ezt az üzenetet kapjuk vissza a Backend Szerveren.</a:t>
+            </a:r>
+            <a:r>
+              <a:rPr lang="hu-HU" sz="1800" b="0" i="0" dirty="0">
+                <a:solidFill>
+                  <a:srgbClr val="000000"/>
+                </a:solidFill>
+                <a:effectLst/>
+                <a:latin typeface="Calibri" panose="020F0502020204030204" pitchFamily="34" charset="0"/>
+              </a:rPr>
+              <a:t>​</a:t>
+            </a:r>
+            <a:endParaRPr lang="hu-HU" dirty="0"/>
+          </a:p>
+        </p:txBody>
+      </p:sp>
+    </p:spTree>
+    <p:extLst>
+      <p:ext uri="{BB962C8B-B14F-4D97-AF65-F5344CB8AC3E}">
+        <p14:creationId xmlns:p14="http://schemas.microsoft.com/office/powerpoint/2010/main" val="579864578"/>
+      </p:ext>
+    </p:extLst>
+  </p:cSld>
+  <p:clrMapOvr>
+    <a:masterClrMapping/>
+  </p:clrMapOvr>
+  <p:transition spd="med">
+    <p:pull/>
+  </p:transition>
+</p:sld>
+</file>
+
 <file path=ppt/slides/slide3.xml><?xml version="1.0" encoding="utf-8"?>
 <p:sld xmlns:a="http://schemas.openxmlformats.org/drawingml/2006/main" xmlns:r="http://schemas.openxmlformats.org/officeDocument/2006/relationships" xmlns:p="http://schemas.openxmlformats.org/presentationml/2006/main">
   <p:cSld>

</xml_diff>